<commit_message>
Improve map of US
</commit_message>
<xml_diff>
--- a/chapter_05/figures/observationa_gridded_dataset.pptx
+++ b/chapter_05/figures/observationa_gridded_dataset.pptx
@@ -125,12 +125,12 @@
   <pc:docChgLst>
     <pc:chgData name="Fatima Pillosu" userId="a6295d4dc9e22643" providerId="LiveId" clId="{87453732-75AC-4426-B5D3-B7C69C2D4F54}"/>
     <pc:docChg chg="undo custSel modSld">
-      <pc:chgData name="Fatima Pillosu" userId="a6295d4dc9e22643" providerId="LiveId" clId="{87453732-75AC-4426-B5D3-B7C69C2D4F54}" dt="2026-01-22T18:03:25.533" v="855" actId="1036"/>
+      <pc:chgData name="Fatima Pillosu" userId="a6295d4dc9e22643" providerId="LiveId" clId="{87453732-75AC-4426-B5D3-B7C69C2D4F54}" dt="2026-01-22T18:21:16.344" v="867" actId="1582"/>
       <pc:docMkLst>
         <pc:docMk/>
       </pc:docMkLst>
       <pc:sldChg chg="addSp delSp modSp mod">
-        <pc:chgData name="Fatima Pillosu" userId="a6295d4dc9e22643" providerId="LiveId" clId="{87453732-75AC-4426-B5D3-B7C69C2D4F54}" dt="2026-01-22T18:03:25.533" v="855" actId="1036"/>
+        <pc:chgData name="Fatima Pillosu" userId="a6295d4dc9e22643" providerId="LiveId" clId="{87453732-75AC-4426-B5D3-B7C69C2D4F54}" dt="2026-01-22T18:21:16.344" v="867" actId="1582"/>
         <pc:sldMkLst>
           <pc:docMk/>
           <pc:sldMk cId="4155273118" sldId="256"/>
@@ -503,6 +503,14 @@
             <ac:grpSpMk id="82" creationId="{872DB2F7-6FAA-CB54-86FF-3765AD701207}"/>
           </ac:grpSpMkLst>
         </pc:grpChg>
+        <pc:picChg chg="add mod">
+          <ac:chgData name="Fatima Pillosu" userId="a6295d4dc9e22643" providerId="LiveId" clId="{87453732-75AC-4426-B5D3-B7C69C2D4F54}" dt="2026-01-22T18:21:16.344" v="867" actId="1582"/>
+          <ac:picMkLst>
+            <pc:docMk/>
+            <pc:sldMk cId="4155273118" sldId="256"/>
+            <ac:picMk id="3" creationId="{2EB6414C-6FBA-B99F-4B11-3F4E2CEE6F13}"/>
+          </ac:picMkLst>
+        </pc:picChg>
         <pc:picChg chg="mod">
           <ac:chgData name="Fatima Pillosu" userId="a6295d4dc9e22643" providerId="LiveId" clId="{87453732-75AC-4426-B5D3-B7C69C2D4F54}" dt="2026-01-22T17:32:51.608" v="538" actId="164"/>
           <ac:picMkLst>
@@ -573,6 +581,14 @@
             <pc:docMk/>
             <pc:sldMk cId="4155273118" sldId="256"/>
             <ac:picMk id="44" creationId="{7C4F1250-5AF8-C7F6-9A78-271C75A6DE07}"/>
+          </ac:picMkLst>
+        </pc:picChg>
+        <pc:picChg chg="del">
+          <ac:chgData name="Fatima Pillosu" userId="a6295d4dc9e22643" providerId="LiveId" clId="{87453732-75AC-4426-B5D3-B7C69C2D4F54}" dt="2026-01-22T18:17:49.610" v="856" actId="478"/>
+          <ac:picMkLst>
+            <pc:docMk/>
+            <pc:sldMk cId="4155273118" sldId="256"/>
+            <ac:picMk id="61" creationId="{F335CD81-03A7-E1AB-27C8-22963CF87DD5}"/>
           </ac:picMkLst>
         </pc:picChg>
         <pc:cxnChg chg="add mod">
@@ -3722,37 +3738,6 @@
         </p:sp>
         <p:pic>
           <p:nvPicPr>
-            <p:cNvPr id="61" name="Picture 60">
-              <a:extLst>
-                <a:ext uri="{FF2B5EF4-FFF2-40B4-BE49-F238E27FC236}">
-                  <a16:creationId xmlns:a16="http://schemas.microsoft.com/office/drawing/2014/main" id="{F335CD81-03A7-E1AB-27C8-22963CF87DD5}"/>
-                </a:ext>
-              </a:extLst>
-            </p:cNvPr>
-            <p:cNvPicPr>
-              <a:picLocks noChangeAspect="1"/>
-            </p:cNvPicPr>
-            <p:nvPr/>
-          </p:nvPicPr>
-          <p:blipFill>
-            <a:blip r:embed="rId2"/>
-            <a:srcRect l="2852" t="4237" r="1628" b="2294"/>
-            <a:stretch>
-              <a:fillRect/>
-            </a:stretch>
-          </p:blipFill>
-          <p:spPr>
-            <a:xfrm>
-              <a:off x="77606" y="1401869"/>
-              <a:ext cx="880800" cy="690931"/>
-            </a:xfrm>
-            <a:prstGeom prst="rect">
-              <a:avLst/>
-            </a:prstGeom>
-          </p:spPr>
-        </p:pic>
-        <p:pic>
-          <p:nvPicPr>
             <p:cNvPr id="62" name="Picture 61">
               <a:extLst>
                 <a:ext uri="{FF2B5EF4-FFF2-40B4-BE49-F238E27FC236}">
@@ -3766,7 +3751,7 @@
             <p:nvPr/>
           </p:nvPicPr>
           <p:blipFill>
-            <a:blip r:embed="rId3"/>
+            <a:blip r:embed="rId2"/>
             <a:srcRect l="13351"/>
             <a:stretch>
               <a:fillRect/>
@@ -4297,7 +4282,7 @@
                 <p:nvPr/>
               </p:nvPicPr>
               <p:blipFill>
-                <a:blip r:embed="rId4"/>
+                <a:blip r:embed="rId3"/>
                 <a:stretch>
                   <a:fillRect/>
                 </a:stretch>
@@ -4536,7 +4521,7 @@
               <p:nvPr/>
             </p:nvPicPr>
             <p:blipFill>
-              <a:blip r:embed="rId5"/>
+              <a:blip r:embed="rId4"/>
               <a:srcRect l="2708" t="1599" r="14583"/>
               <a:stretch>
                 <a:fillRect/>
@@ -4664,7 +4649,7 @@
               <p:nvPr/>
             </p:nvPicPr>
             <p:blipFill>
-              <a:blip r:embed="rId6"/>
+              <a:blip r:embed="rId5"/>
               <a:stretch>
                 <a:fillRect/>
               </a:stretch>
@@ -4905,6 +4890,44 @@
           </a:fontRef>
         </p:style>
       </p:cxnSp>
+      <p:pic>
+        <p:nvPicPr>
+          <p:cNvPr id="3" name="Picture 2">
+            <a:extLst>
+              <a:ext uri="{FF2B5EF4-FFF2-40B4-BE49-F238E27FC236}">
+                <a16:creationId xmlns:a16="http://schemas.microsoft.com/office/drawing/2014/main" id="{2EB6414C-6FBA-B99F-4B11-3F4E2CEE6F13}"/>
+              </a:ext>
+            </a:extLst>
+          </p:cNvPr>
+          <p:cNvPicPr>
+            <a:picLocks noChangeAspect="1"/>
+          </p:cNvPicPr>
+          <p:nvPr/>
+        </p:nvPicPr>
+        <p:blipFill>
+          <a:blip r:embed="rId6"/>
+          <a:stretch>
+            <a:fillRect/>
+          </a:stretch>
+        </p:blipFill>
+        <p:spPr>
+          <a:xfrm>
+            <a:off x="115378" y="2072235"/>
+            <a:ext cx="817549" cy="639543"/>
+          </a:xfrm>
+          <a:prstGeom prst="rect">
+            <a:avLst/>
+          </a:prstGeom>
+          <a:ln w="9525">
+            <a:solidFill>
+              <a:schemeClr val="tx1">
+                <a:lumMod val="50000"/>
+                <a:lumOff val="50000"/>
+              </a:schemeClr>
+            </a:solidFill>
+          </a:ln>
+        </p:spPr>
+      </p:pic>
     </p:spTree>
     <p:extLst>
       <p:ext uri="{BB962C8B-B14F-4D97-AF65-F5344CB8AC3E}">

</xml_diff>